<commit_message>
Slides das Aulas 13, 14, 16, 18 e 19 sincronizados com o Drive (cabeçalho e rodapé padronizados)
Co-Authored-By: Claude Opus 5.5 <noreply@anthropic.com>
</commit_message>
<xml_diff>
--- a/content/2026-2/cea055-estatistica-probabilidade/13-modelos-continuos-ii-normal/Aula_13_Modelos_Continuos_II_Normal.pptx
+++ b/content/2026-2/cea055-estatistica-probabilidade/13-modelos-continuos-ii-normal/Aula_13_Modelos_Continuos_II_Normal.pptx
@@ -4668,56 +4668,6 @@
       </p:grpSpPr>
       <p:sp>
         <p:nvSpPr>
-          <p:cNvPr id="2" name="Título 1">
-            <a:extLst>
-              <a:ext uri="{FF2B5EF4-FFF2-40B4-BE49-F238E27FC236}">
-                <a16:creationId xmlns:a16="http://schemas.microsoft.com/office/drawing/2014/main" id="{BC798918-7CB4-450A-A042-F0B538CA25DE}"/>
-              </a:ext>
-            </a:extLst>
-          </p:cNvPr>
-          <p:cNvSpPr>
-            <a:spLocks noGrp="1"/>
-          </p:cNvSpPr>
-          <p:nvPr>
-            <p:ph type="title"/>
-          </p:nvPr>
-        </p:nvSpPr>
-        <p:spPr>
-          <a:xfrm>
-            <a:off x="1032611" y="0"/>
-            <a:ext cx="10827959" cy="1574800"/>
-          </a:xfrm>
-        </p:spPr>
-        <p:txBody>
-          <a:bodyPr>
-            <a:normAutofit/>
-          </a:bodyPr>
-          <a:lstStyle/>
-          <a:p>
-            <a:pPr algn="ctr"/>
-            <a:r>
-              <a:rPr lang="pt-BR" dirty="0">
-                <a:latin typeface="AlternateGothic2 BT" panose="020B0608020202050204" pitchFamily="34" charset="0"/>
-              </a:rPr>
-              <a:t>CEA055 – Estatística e Probabilidade</a:t>
-            </a:r>
-            <a:br>
-              <a:rPr lang="pt-BR" dirty="0">
-                <a:latin typeface="AlternateGothic2 BT" panose="020B0608020202050204" pitchFamily="34" charset="0"/>
-              </a:rPr>
-            </a:br>
-            <a:r>
-              <a:rPr lang="pt-BR" sz="2200" b="1" dirty="0"/>
-              <a:t>Variáveis aleatórias continuas</a:t>
-            </a:r>
-            <a:endParaRPr lang="pt-BR" dirty="0">
-              <a:latin typeface="AlternateGothic2 BT" panose="020B0608020202050204" pitchFamily="34" charset="0"/>
-            </a:endParaRPr>
-          </a:p>
-        </p:txBody>
-      </p:sp>
-      <p:sp>
-        <p:nvSpPr>
           <p:cNvPr id="6" name="CaixaDeTexto 5">
             <a:extLst>
               <a:ext uri="{FF2B5EF4-FFF2-40B4-BE49-F238E27FC236}">
@@ -4784,7 +4734,7 @@
         <p:spPr>
           <a:xfrm>
             <a:off x="361395" y="6488668"/>
-            <a:ext cx="2395336" cy="300210"/>
+            <a:ext cx="7620000" cy="300210"/>
           </a:xfrm>
           <a:prstGeom prst="rect">
             <a:avLst/>
@@ -4799,47 +4749,11 @@
           <a:p>
             <a:r>
               <a:rPr lang="pt-BR" sz="1351" dirty="0"/>
-              <a:t>Professor: Marcos Goulart Lima</a:t>
+              <a:t>CEA055 - Estatística e Probabilidade - Professor: Marcos Goulart Lima</a:t>
             </a:r>
           </a:p>
         </p:txBody>
       </p:sp>
-      <p:pic>
-        <p:nvPicPr>
-          <p:cNvPr id="8" name="Espaço Reservado para Conteúdo 4">
-            <a:extLst>
-              <a:ext uri="{FF2B5EF4-FFF2-40B4-BE49-F238E27FC236}">
-                <a16:creationId xmlns:a16="http://schemas.microsoft.com/office/drawing/2014/main" id="{65AB402D-D1A8-4F31-BA42-34A6F0FC69F9}"/>
-              </a:ext>
-            </a:extLst>
-          </p:cNvPr>
-          <p:cNvPicPr>
-            <a:picLocks noChangeAspect="1"/>
-          </p:cNvPicPr>
-          <p:nvPr/>
-        </p:nvPicPr>
-        <p:blipFill>
-          <a:blip r:embed="rId2">
-            <a:extLst>
-              <a:ext uri="{28A0092B-C50C-407E-A947-70E740481C1C}">
-                <a14:useLocalDpi xmlns:a14="http://schemas.microsoft.com/office/drawing/2010/main" val="0"/>
-              </a:ext>
-            </a:extLst>
-          </a:blip>
-          <a:stretch>
-            <a:fillRect/>
-          </a:stretch>
-        </p:blipFill>
-        <p:spPr>
-          <a:xfrm>
-            <a:off x="62144" y="112237"/>
-            <a:ext cx="588096" cy="1228523"/>
-          </a:xfrm>
-          <a:prstGeom prst="rect">
-            <a:avLst/>
-          </a:prstGeom>
-        </p:spPr>
-      </p:pic>
     </p:spTree>
     <p:extLst>
       <p:ext uri="{BB962C8B-B14F-4D97-AF65-F5344CB8AC3E}">
@@ -4885,7 +4799,7 @@
         <p:spPr>
           <a:xfrm>
             <a:off x="361395" y="6488668"/>
-            <a:ext cx="2395336" cy="300210"/>
+            <a:ext cx="7620000" cy="300210"/>
           </a:xfrm>
           <a:prstGeom prst="rect">
             <a:avLst/>
@@ -4900,47 +4814,11 @@
           <a:p>
             <a:r>
               <a:rPr lang="pt-BR" sz="1351" dirty="0"/>
-              <a:t>Professor: Marcos Goulart Lima</a:t>
+              <a:t>CEA055 - Estatística e Probabilidade - Professor: Marcos Goulart Lima</a:t>
             </a:r>
           </a:p>
         </p:txBody>
       </p:sp>
-      <p:pic>
-        <p:nvPicPr>
-          <p:cNvPr id="8" name="Espaço Reservado para Conteúdo 4">
-            <a:extLst>
-              <a:ext uri="{FF2B5EF4-FFF2-40B4-BE49-F238E27FC236}">
-                <a16:creationId xmlns:a16="http://schemas.microsoft.com/office/drawing/2014/main" id="{65AB402D-D1A8-4F31-BA42-34A6F0FC69F9}"/>
-              </a:ext>
-            </a:extLst>
-          </p:cNvPr>
-          <p:cNvPicPr>
-            <a:picLocks noChangeAspect="1"/>
-          </p:cNvPicPr>
-          <p:nvPr/>
-        </p:nvPicPr>
-        <p:blipFill>
-          <a:blip r:embed="rId2">
-            <a:extLst>
-              <a:ext uri="{28A0092B-C50C-407E-A947-70E740481C1C}">
-                <a14:useLocalDpi xmlns:a14="http://schemas.microsoft.com/office/drawing/2010/main" val="0"/>
-              </a:ext>
-            </a:extLst>
-          </a:blip>
-          <a:stretch>
-            <a:fillRect/>
-          </a:stretch>
-        </p:blipFill>
-        <p:spPr>
-          <a:xfrm>
-            <a:off x="62144" y="112237"/>
-            <a:ext cx="588096" cy="1228523"/>
-          </a:xfrm>
-          <a:prstGeom prst="rect">
-            <a:avLst/>
-          </a:prstGeom>
-        </p:spPr>
-      </p:pic>
       <p:pic>
         <p:nvPicPr>
           <p:cNvPr id="1026" name="Picture 2" descr="Tabela da distribuição Normal Padrão">
@@ -5063,7 +4941,7 @@
         <p:spPr>
           <a:xfrm>
             <a:off x="361395" y="6488668"/>
-            <a:ext cx="2395336" cy="300210"/>
+            <a:ext cx="7620000" cy="300210"/>
           </a:xfrm>
           <a:prstGeom prst="rect">
             <a:avLst/>
@@ -5078,47 +4956,11 @@
           <a:p>
             <a:r>
               <a:rPr lang="pt-BR" sz="1351" dirty="0"/>
-              <a:t>Professor: Marcos Goulart Lima</a:t>
+              <a:t>CEA055 - Estatística e Probabilidade - Professor: Marcos Goulart Lima</a:t>
             </a:r>
           </a:p>
         </p:txBody>
       </p:sp>
-      <p:pic>
-        <p:nvPicPr>
-          <p:cNvPr id="8" name="Espaço Reservado para Conteúdo 4">
-            <a:extLst>
-              <a:ext uri="{FF2B5EF4-FFF2-40B4-BE49-F238E27FC236}">
-                <a16:creationId xmlns:a16="http://schemas.microsoft.com/office/drawing/2014/main" id="{65AB402D-D1A8-4F31-BA42-34A6F0FC69F9}"/>
-              </a:ext>
-            </a:extLst>
-          </p:cNvPr>
-          <p:cNvPicPr>
-            <a:picLocks noChangeAspect="1"/>
-          </p:cNvPicPr>
-          <p:nvPr/>
-        </p:nvPicPr>
-        <p:blipFill>
-          <a:blip r:embed="rId2">
-            <a:extLst>
-              <a:ext uri="{28A0092B-C50C-407E-A947-70E740481C1C}">
-                <a14:useLocalDpi xmlns:a14="http://schemas.microsoft.com/office/drawing/2010/main" val="0"/>
-              </a:ext>
-            </a:extLst>
-          </a:blip>
-          <a:stretch>
-            <a:fillRect/>
-          </a:stretch>
-        </p:blipFill>
-        <p:spPr>
-          <a:xfrm>
-            <a:off x="62144" y="112237"/>
-            <a:ext cx="588096" cy="1228523"/>
-          </a:xfrm>
-          <a:prstGeom prst="rect">
-            <a:avLst/>
-          </a:prstGeom>
-        </p:spPr>
-      </p:pic>
       <p:pic>
         <p:nvPicPr>
           <p:cNvPr id="2050" name="Picture 2">
@@ -5241,7 +5083,7 @@
         <p:spPr>
           <a:xfrm>
             <a:off x="361395" y="6488668"/>
-            <a:ext cx="2395336" cy="300210"/>
+            <a:ext cx="7620000" cy="300210"/>
           </a:xfrm>
           <a:prstGeom prst="rect">
             <a:avLst/>
@@ -5256,47 +5098,11 @@
           <a:p>
             <a:r>
               <a:rPr lang="pt-BR" sz="1351" dirty="0"/>
-              <a:t>Professor: Marcos Goulart Lima</a:t>
+              <a:t>CEA055 - Estatística e Probabilidade - Professor: Marcos Goulart Lima</a:t>
             </a:r>
           </a:p>
         </p:txBody>
       </p:sp>
-      <p:pic>
-        <p:nvPicPr>
-          <p:cNvPr id="8" name="Espaço Reservado para Conteúdo 4">
-            <a:extLst>
-              <a:ext uri="{FF2B5EF4-FFF2-40B4-BE49-F238E27FC236}">
-                <a16:creationId xmlns:a16="http://schemas.microsoft.com/office/drawing/2014/main" id="{65AB402D-D1A8-4F31-BA42-34A6F0FC69F9}"/>
-              </a:ext>
-            </a:extLst>
-          </p:cNvPr>
-          <p:cNvPicPr>
-            <a:picLocks noChangeAspect="1"/>
-          </p:cNvPicPr>
-          <p:nvPr/>
-        </p:nvPicPr>
-        <p:blipFill>
-          <a:blip r:embed="rId2">
-            <a:extLst>
-              <a:ext uri="{28A0092B-C50C-407E-A947-70E740481C1C}">
-                <a14:useLocalDpi xmlns:a14="http://schemas.microsoft.com/office/drawing/2010/main" val="0"/>
-              </a:ext>
-            </a:extLst>
-          </a:blip>
-          <a:stretch>
-            <a:fillRect/>
-          </a:stretch>
-        </p:blipFill>
-        <p:spPr>
-          <a:xfrm>
-            <a:off x="62144" y="112237"/>
-            <a:ext cx="588096" cy="1228523"/>
-          </a:xfrm>
-          <a:prstGeom prst="rect">
-            <a:avLst/>
-          </a:prstGeom>
-        </p:spPr>
-      </p:pic>
       <p:pic>
         <p:nvPicPr>
           <p:cNvPr id="3074" name="Picture 2">
@@ -5404,56 +5210,6 @@
           <a:chExt cx="0" cy="0"/>
         </a:xfrm>
       </p:grpSpPr>
-      <p:sp>
-        <p:nvSpPr>
-          <p:cNvPr id="2" name="Título 1">
-            <a:extLst>
-              <a:ext uri="{FF2B5EF4-FFF2-40B4-BE49-F238E27FC236}">
-                <a16:creationId xmlns:a16="http://schemas.microsoft.com/office/drawing/2014/main" id="{BC798918-7CB4-450A-A042-F0B538CA25DE}"/>
-              </a:ext>
-            </a:extLst>
-          </p:cNvPr>
-          <p:cNvSpPr>
-            <a:spLocks noGrp="1"/>
-          </p:cNvSpPr>
-          <p:nvPr>
-            <p:ph type="title"/>
-          </p:nvPr>
-        </p:nvSpPr>
-        <p:spPr>
-          <a:xfrm>
-            <a:off x="1032611" y="0"/>
-            <a:ext cx="10827959" cy="1574800"/>
-          </a:xfrm>
-        </p:spPr>
-        <p:txBody>
-          <a:bodyPr>
-            <a:normAutofit/>
-          </a:bodyPr>
-          <a:lstStyle/>
-          <a:p>
-            <a:pPr algn="ctr"/>
-            <a:r>
-              <a:rPr lang="pt-BR" dirty="0">
-                <a:latin typeface="AlternateGothic2 BT" panose="020B0608020202050204" pitchFamily="34" charset="0"/>
-              </a:rPr>
-              <a:t>CEA055 – Estatística e Probabilidade</a:t>
-            </a:r>
-            <a:br>
-              <a:rPr lang="pt-BR" dirty="0">
-                <a:latin typeface="AlternateGothic2 BT" panose="020B0608020202050204" pitchFamily="34" charset="0"/>
-              </a:rPr>
-            </a:br>
-            <a:r>
-              <a:rPr lang="pt-BR" sz="2200" b="1" dirty="0"/>
-              <a:t>Variáveis aleatórias continuas</a:t>
-            </a:r>
-            <a:endParaRPr lang="pt-BR" dirty="0">
-              <a:latin typeface="AlternateGothic2 BT" panose="020B0608020202050204" pitchFamily="34" charset="0"/>
-            </a:endParaRPr>
-          </a:p>
-        </p:txBody>
-      </p:sp>
       <mc:AlternateContent xmlns:mc="http://schemas.openxmlformats.org/markup-compatibility/2006" xmlns:a14="http://schemas.microsoft.com/office/drawing/2010/main">
         <mc:Choice Requires="a14">
           <p:sp>
@@ -5902,7 +5658,7 @@
         <p:spPr>
           <a:xfrm>
             <a:off x="361395" y="6488668"/>
-            <a:ext cx="2395336" cy="300210"/>
+            <a:ext cx="7620000" cy="300210"/>
           </a:xfrm>
           <a:prstGeom prst="rect">
             <a:avLst/>
@@ -5917,47 +5673,11 @@
           <a:p>
             <a:r>
               <a:rPr lang="pt-BR" sz="1351" dirty="0"/>
-              <a:t>Professor: Marcos Goulart Lima</a:t>
+              <a:t>CEA055 - Estatística e Probabilidade - Professor: Marcos Goulart Lima</a:t>
             </a:r>
           </a:p>
         </p:txBody>
       </p:sp>
-      <p:pic>
-        <p:nvPicPr>
-          <p:cNvPr id="8" name="Espaço Reservado para Conteúdo 4">
-            <a:extLst>
-              <a:ext uri="{FF2B5EF4-FFF2-40B4-BE49-F238E27FC236}">
-                <a16:creationId xmlns:a16="http://schemas.microsoft.com/office/drawing/2014/main" id="{65AB402D-D1A8-4F31-BA42-34A6F0FC69F9}"/>
-              </a:ext>
-            </a:extLst>
-          </p:cNvPr>
-          <p:cNvPicPr>
-            <a:picLocks noChangeAspect="1"/>
-          </p:cNvPicPr>
-          <p:nvPr/>
-        </p:nvPicPr>
-        <p:blipFill>
-          <a:blip r:embed="rId3">
-            <a:extLst>
-              <a:ext uri="{28A0092B-C50C-407E-A947-70E740481C1C}">
-                <a14:useLocalDpi xmlns:a14="http://schemas.microsoft.com/office/drawing/2010/main" val="0"/>
-              </a:ext>
-            </a:extLst>
-          </a:blip>
-          <a:stretch>
-            <a:fillRect/>
-          </a:stretch>
-        </p:blipFill>
-        <p:spPr>
-          <a:xfrm>
-            <a:off x="62144" y="112237"/>
-            <a:ext cx="588096" cy="1228523"/>
-          </a:xfrm>
-          <a:prstGeom prst="rect">
-            <a:avLst/>
-          </a:prstGeom>
-        </p:spPr>
-      </p:pic>
     </p:spTree>
     <p:extLst>
       <p:ext uri="{BB962C8B-B14F-4D97-AF65-F5344CB8AC3E}">
@@ -5988,56 +5708,6 @@
           <a:chExt cx="0" cy="0"/>
         </a:xfrm>
       </p:grpSpPr>
-      <p:sp>
-        <p:nvSpPr>
-          <p:cNvPr id="2" name="Título 1">
-            <a:extLst>
-              <a:ext uri="{FF2B5EF4-FFF2-40B4-BE49-F238E27FC236}">
-                <a16:creationId xmlns:a16="http://schemas.microsoft.com/office/drawing/2014/main" id="{BC798918-7CB4-450A-A042-F0B538CA25DE}"/>
-              </a:ext>
-            </a:extLst>
-          </p:cNvPr>
-          <p:cNvSpPr>
-            <a:spLocks noGrp="1"/>
-          </p:cNvSpPr>
-          <p:nvPr>
-            <p:ph type="title"/>
-          </p:nvPr>
-        </p:nvSpPr>
-        <p:spPr>
-          <a:xfrm>
-            <a:off x="1032611" y="0"/>
-            <a:ext cx="10827959" cy="1574800"/>
-          </a:xfrm>
-        </p:spPr>
-        <p:txBody>
-          <a:bodyPr>
-            <a:normAutofit/>
-          </a:bodyPr>
-          <a:lstStyle/>
-          <a:p>
-            <a:pPr algn="ctr"/>
-            <a:r>
-              <a:rPr lang="pt-BR" dirty="0">
-                <a:latin typeface="AlternateGothic2 BT" panose="020B0608020202050204" pitchFamily="34" charset="0"/>
-              </a:rPr>
-              <a:t>CEA055 – Estatística e Probabilidade</a:t>
-            </a:r>
-            <a:br>
-              <a:rPr lang="pt-BR" dirty="0">
-                <a:latin typeface="AlternateGothic2 BT" panose="020B0608020202050204" pitchFamily="34" charset="0"/>
-              </a:rPr>
-            </a:br>
-            <a:r>
-              <a:rPr lang="pt-BR" sz="2200" b="1" dirty="0"/>
-              <a:t>Variáveis aleatórias continuas</a:t>
-            </a:r>
-            <a:endParaRPr lang="pt-BR" dirty="0">
-              <a:latin typeface="AlternateGothic2 BT" panose="020B0608020202050204" pitchFamily="34" charset="0"/>
-            </a:endParaRPr>
-          </a:p>
-        </p:txBody>
-      </p:sp>
       <mc:AlternateContent xmlns:mc="http://schemas.openxmlformats.org/markup-compatibility/2006" xmlns:a14="http://schemas.microsoft.com/office/drawing/2010/main">
         <mc:Choice Requires="a14">
           <p:sp>
@@ -6532,7 +6202,7 @@
         <p:spPr>
           <a:xfrm>
             <a:off x="361395" y="6488668"/>
-            <a:ext cx="2395336" cy="300210"/>
+            <a:ext cx="7620000" cy="300210"/>
           </a:xfrm>
           <a:prstGeom prst="rect">
             <a:avLst/>
@@ -6547,47 +6217,11 @@
           <a:p>
             <a:r>
               <a:rPr lang="pt-BR" sz="1351" dirty="0"/>
-              <a:t>Professor: Marcos Goulart Lima</a:t>
+              <a:t>CEA055 - Estatística e Probabilidade - Professor: Marcos Goulart Lima</a:t>
             </a:r>
           </a:p>
         </p:txBody>
       </p:sp>
-      <p:pic>
-        <p:nvPicPr>
-          <p:cNvPr id="8" name="Espaço Reservado para Conteúdo 4">
-            <a:extLst>
-              <a:ext uri="{FF2B5EF4-FFF2-40B4-BE49-F238E27FC236}">
-                <a16:creationId xmlns:a16="http://schemas.microsoft.com/office/drawing/2014/main" id="{65AB402D-D1A8-4F31-BA42-34A6F0FC69F9}"/>
-              </a:ext>
-            </a:extLst>
-          </p:cNvPr>
-          <p:cNvPicPr>
-            <a:picLocks noChangeAspect="1"/>
-          </p:cNvPicPr>
-          <p:nvPr/>
-        </p:nvPicPr>
-        <p:blipFill>
-          <a:blip r:embed="rId3">
-            <a:extLst>
-              <a:ext uri="{28A0092B-C50C-407E-A947-70E740481C1C}">
-                <a14:useLocalDpi xmlns:a14="http://schemas.microsoft.com/office/drawing/2010/main" val="0"/>
-              </a:ext>
-            </a:extLst>
-          </a:blip>
-          <a:stretch>
-            <a:fillRect/>
-          </a:stretch>
-        </p:blipFill>
-        <p:spPr>
-          <a:xfrm>
-            <a:off x="62144" y="112237"/>
-            <a:ext cx="588096" cy="1228523"/>
-          </a:xfrm>
-          <a:prstGeom prst="rect">
-            <a:avLst/>
-          </a:prstGeom>
-        </p:spPr>
-      </p:pic>
     </p:spTree>
     <p:extLst>
       <p:ext uri="{BB962C8B-B14F-4D97-AF65-F5344CB8AC3E}">
@@ -6618,56 +6252,6 @@
           <a:chExt cx="0" cy="0"/>
         </a:xfrm>
       </p:grpSpPr>
-      <p:sp>
-        <p:nvSpPr>
-          <p:cNvPr id="2" name="Título 1">
-            <a:extLst>
-              <a:ext uri="{FF2B5EF4-FFF2-40B4-BE49-F238E27FC236}">
-                <a16:creationId xmlns:a16="http://schemas.microsoft.com/office/drawing/2014/main" id="{BC798918-7CB4-450A-A042-F0B538CA25DE}"/>
-              </a:ext>
-            </a:extLst>
-          </p:cNvPr>
-          <p:cNvSpPr>
-            <a:spLocks noGrp="1"/>
-          </p:cNvSpPr>
-          <p:nvPr>
-            <p:ph type="title"/>
-          </p:nvPr>
-        </p:nvSpPr>
-        <p:spPr>
-          <a:xfrm>
-            <a:off x="1032611" y="0"/>
-            <a:ext cx="10827959" cy="1574800"/>
-          </a:xfrm>
-        </p:spPr>
-        <p:txBody>
-          <a:bodyPr>
-            <a:normAutofit/>
-          </a:bodyPr>
-          <a:lstStyle/>
-          <a:p>
-            <a:pPr algn="ctr"/>
-            <a:r>
-              <a:rPr lang="pt-BR" dirty="0">
-                <a:latin typeface="AlternateGothic2 BT" panose="020B0608020202050204" pitchFamily="34" charset="0"/>
-              </a:rPr>
-              <a:t>CEA055 – Estatística e Probabilidade</a:t>
-            </a:r>
-            <a:br>
-              <a:rPr lang="pt-BR" dirty="0">
-                <a:latin typeface="AlternateGothic2 BT" panose="020B0608020202050204" pitchFamily="34" charset="0"/>
-              </a:rPr>
-            </a:br>
-            <a:r>
-              <a:rPr lang="pt-BR" sz="2200" b="1" dirty="0"/>
-              <a:t>Variáveis aleatórias continuas</a:t>
-            </a:r>
-            <a:endParaRPr lang="pt-BR" dirty="0">
-              <a:latin typeface="AlternateGothic2 BT" panose="020B0608020202050204" pitchFamily="34" charset="0"/>
-            </a:endParaRPr>
-          </a:p>
-        </p:txBody>
-      </p:sp>
       <mc:AlternateContent xmlns:mc="http://schemas.openxmlformats.org/markup-compatibility/2006" xmlns:a14="http://schemas.microsoft.com/office/drawing/2010/main">
         <mc:Choice Requires="a14">
           <p:sp>
@@ -7007,7 +6591,7 @@
         <p:spPr>
           <a:xfrm>
             <a:off x="361395" y="6488668"/>
-            <a:ext cx="2395336" cy="300210"/>
+            <a:ext cx="7620000" cy="300210"/>
           </a:xfrm>
           <a:prstGeom prst="rect">
             <a:avLst/>
@@ -7022,47 +6606,11 @@
           <a:p>
             <a:r>
               <a:rPr lang="pt-BR" sz="1351" dirty="0"/>
-              <a:t>Professor: Marcos Goulart Lima</a:t>
+              <a:t>CEA055 - Estatística e Probabilidade - Professor: Marcos Goulart Lima</a:t>
             </a:r>
           </a:p>
         </p:txBody>
       </p:sp>
-      <p:pic>
-        <p:nvPicPr>
-          <p:cNvPr id="8" name="Espaço Reservado para Conteúdo 4">
-            <a:extLst>
-              <a:ext uri="{FF2B5EF4-FFF2-40B4-BE49-F238E27FC236}">
-                <a16:creationId xmlns:a16="http://schemas.microsoft.com/office/drawing/2014/main" id="{65AB402D-D1A8-4F31-BA42-34A6F0FC69F9}"/>
-              </a:ext>
-            </a:extLst>
-          </p:cNvPr>
-          <p:cNvPicPr>
-            <a:picLocks noChangeAspect="1"/>
-          </p:cNvPicPr>
-          <p:nvPr/>
-        </p:nvPicPr>
-        <p:blipFill>
-          <a:blip r:embed="rId3">
-            <a:extLst>
-              <a:ext uri="{28A0092B-C50C-407E-A947-70E740481C1C}">
-                <a14:useLocalDpi xmlns:a14="http://schemas.microsoft.com/office/drawing/2010/main" val="0"/>
-              </a:ext>
-            </a:extLst>
-          </a:blip>
-          <a:stretch>
-            <a:fillRect/>
-          </a:stretch>
-        </p:blipFill>
-        <p:spPr>
-          <a:xfrm>
-            <a:off x="62144" y="112237"/>
-            <a:ext cx="588096" cy="1228523"/>
-          </a:xfrm>
-          <a:prstGeom prst="rect">
-            <a:avLst/>
-          </a:prstGeom>
-        </p:spPr>
-      </p:pic>
     </p:spTree>
     <p:extLst>
       <p:ext uri="{BB962C8B-B14F-4D97-AF65-F5344CB8AC3E}">
@@ -7093,56 +6641,6 @@
           <a:chExt cx="0" cy="0"/>
         </a:xfrm>
       </p:grpSpPr>
-      <p:sp>
-        <p:nvSpPr>
-          <p:cNvPr id="2" name="Título 1">
-            <a:extLst>
-              <a:ext uri="{FF2B5EF4-FFF2-40B4-BE49-F238E27FC236}">
-                <a16:creationId xmlns:a16="http://schemas.microsoft.com/office/drawing/2014/main" id="{BC798918-7CB4-450A-A042-F0B538CA25DE}"/>
-              </a:ext>
-            </a:extLst>
-          </p:cNvPr>
-          <p:cNvSpPr>
-            <a:spLocks noGrp="1"/>
-          </p:cNvSpPr>
-          <p:nvPr>
-            <p:ph type="title"/>
-          </p:nvPr>
-        </p:nvSpPr>
-        <p:spPr>
-          <a:xfrm>
-            <a:off x="1032611" y="0"/>
-            <a:ext cx="10827959" cy="1574800"/>
-          </a:xfrm>
-        </p:spPr>
-        <p:txBody>
-          <a:bodyPr>
-            <a:normAutofit/>
-          </a:bodyPr>
-          <a:lstStyle/>
-          <a:p>
-            <a:pPr algn="ctr"/>
-            <a:r>
-              <a:rPr lang="pt-BR" dirty="0">
-                <a:latin typeface="AlternateGothic2 BT" panose="020B0608020202050204" pitchFamily="34" charset="0"/>
-              </a:rPr>
-              <a:t>CEA055 – Estatística e Probabilidade</a:t>
-            </a:r>
-            <a:br>
-              <a:rPr lang="pt-BR" dirty="0">
-                <a:latin typeface="AlternateGothic2 BT" panose="020B0608020202050204" pitchFamily="34" charset="0"/>
-              </a:rPr>
-            </a:br>
-            <a:r>
-              <a:rPr lang="pt-BR" sz="2200" b="1" dirty="0"/>
-              <a:t>Variáveis aleatórias continuas</a:t>
-            </a:r>
-            <a:endParaRPr lang="pt-BR" dirty="0">
-              <a:latin typeface="AlternateGothic2 BT" panose="020B0608020202050204" pitchFamily="34" charset="0"/>
-            </a:endParaRPr>
-          </a:p>
-        </p:txBody>
-      </p:sp>
       <mc:AlternateContent xmlns:mc="http://schemas.openxmlformats.org/markup-compatibility/2006" xmlns:a14="http://schemas.microsoft.com/office/drawing/2010/main">
         <mc:Choice Requires="a14">
           <p:sp>
@@ -7537,7 +7035,7 @@
         <p:spPr>
           <a:xfrm>
             <a:off x="361395" y="6488668"/>
-            <a:ext cx="2395336" cy="300210"/>
+            <a:ext cx="7620000" cy="300210"/>
           </a:xfrm>
           <a:prstGeom prst="rect">
             <a:avLst/>
@@ -7552,47 +7050,11 @@
           <a:p>
             <a:r>
               <a:rPr lang="pt-BR" sz="1351" dirty="0"/>
-              <a:t>Professor: Marcos Goulart Lima</a:t>
+              <a:t>CEA055 - Estatística e Probabilidade - Professor: Marcos Goulart Lima</a:t>
             </a:r>
           </a:p>
         </p:txBody>
       </p:sp>
-      <p:pic>
-        <p:nvPicPr>
-          <p:cNvPr id="8" name="Espaço Reservado para Conteúdo 4">
-            <a:extLst>
-              <a:ext uri="{FF2B5EF4-FFF2-40B4-BE49-F238E27FC236}">
-                <a16:creationId xmlns:a16="http://schemas.microsoft.com/office/drawing/2014/main" id="{65AB402D-D1A8-4F31-BA42-34A6F0FC69F9}"/>
-              </a:ext>
-            </a:extLst>
-          </p:cNvPr>
-          <p:cNvPicPr>
-            <a:picLocks noChangeAspect="1"/>
-          </p:cNvPicPr>
-          <p:nvPr/>
-        </p:nvPicPr>
-        <p:blipFill>
-          <a:blip r:embed="rId3">
-            <a:extLst>
-              <a:ext uri="{28A0092B-C50C-407E-A947-70E740481C1C}">
-                <a14:useLocalDpi xmlns:a14="http://schemas.microsoft.com/office/drawing/2010/main" val="0"/>
-              </a:ext>
-            </a:extLst>
-          </a:blip>
-          <a:stretch>
-            <a:fillRect/>
-          </a:stretch>
-        </p:blipFill>
-        <p:spPr>
-          <a:xfrm>
-            <a:off x="62144" y="112237"/>
-            <a:ext cx="588096" cy="1228523"/>
-          </a:xfrm>
-          <a:prstGeom prst="rect">
-            <a:avLst/>
-          </a:prstGeom>
-        </p:spPr>
-      </p:pic>
     </p:spTree>
     <p:extLst>
       <p:ext uri="{BB962C8B-B14F-4D97-AF65-F5344CB8AC3E}">
@@ -7623,56 +7085,6 @@
           <a:chExt cx="0" cy="0"/>
         </a:xfrm>
       </p:grpSpPr>
-      <p:sp>
-        <p:nvSpPr>
-          <p:cNvPr id="2" name="Título 1">
-            <a:extLst>
-              <a:ext uri="{FF2B5EF4-FFF2-40B4-BE49-F238E27FC236}">
-                <a16:creationId xmlns:a16="http://schemas.microsoft.com/office/drawing/2014/main" id="{BC798918-7CB4-450A-A042-F0B538CA25DE}"/>
-              </a:ext>
-            </a:extLst>
-          </p:cNvPr>
-          <p:cNvSpPr>
-            <a:spLocks noGrp="1"/>
-          </p:cNvSpPr>
-          <p:nvPr>
-            <p:ph type="title"/>
-          </p:nvPr>
-        </p:nvSpPr>
-        <p:spPr>
-          <a:xfrm>
-            <a:off x="1032611" y="0"/>
-            <a:ext cx="10827959" cy="1574800"/>
-          </a:xfrm>
-        </p:spPr>
-        <p:txBody>
-          <a:bodyPr>
-            <a:normAutofit/>
-          </a:bodyPr>
-          <a:lstStyle/>
-          <a:p>
-            <a:pPr algn="ctr"/>
-            <a:r>
-              <a:rPr lang="pt-BR" dirty="0">
-                <a:latin typeface="AlternateGothic2 BT" panose="020B0608020202050204" pitchFamily="34" charset="0"/>
-              </a:rPr>
-              <a:t>CEA055 – Estatística e Probabilidade</a:t>
-            </a:r>
-            <a:br>
-              <a:rPr lang="pt-BR" dirty="0">
-                <a:latin typeface="AlternateGothic2 BT" panose="020B0608020202050204" pitchFamily="34" charset="0"/>
-              </a:rPr>
-            </a:br>
-            <a:r>
-              <a:rPr lang="pt-BR" sz="2200" b="1" dirty="0"/>
-              <a:t>Variáveis aleatórias continuas</a:t>
-            </a:r>
-            <a:endParaRPr lang="pt-BR" dirty="0">
-              <a:latin typeface="AlternateGothic2 BT" panose="020B0608020202050204" pitchFamily="34" charset="0"/>
-            </a:endParaRPr>
-          </a:p>
-        </p:txBody>
-      </p:sp>
       <mc:AlternateContent xmlns:mc="http://schemas.openxmlformats.org/markup-compatibility/2006" xmlns:a14="http://schemas.microsoft.com/office/drawing/2010/main">
         <mc:Choice Requires="a14">
           <p:sp>
@@ -7887,7 +7299,7 @@
         <p:spPr>
           <a:xfrm>
             <a:off x="361395" y="6488668"/>
-            <a:ext cx="2395336" cy="300210"/>
+            <a:ext cx="7620000" cy="300210"/>
           </a:xfrm>
           <a:prstGeom prst="rect">
             <a:avLst/>
@@ -7902,47 +7314,11 @@
           <a:p>
             <a:r>
               <a:rPr lang="pt-BR" sz="1351" dirty="0"/>
-              <a:t>Professor: Marcos Goulart Lima</a:t>
+              <a:t>CEA055 - Estatística e Probabilidade - Professor: Marcos Goulart Lima</a:t>
             </a:r>
           </a:p>
         </p:txBody>
       </p:sp>
-      <p:pic>
-        <p:nvPicPr>
-          <p:cNvPr id="8" name="Espaço Reservado para Conteúdo 4">
-            <a:extLst>
-              <a:ext uri="{FF2B5EF4-FFF2-40B4-BE49-F238E27FC236}">
-                <a16:creationId xmlns:a16="http://schemas.microsoft.com/office/drawing/2014/main" id="{65AB402D-D1A8-4F31-BA42-34A6F0FC69F9}"/>
-              </a:ext>
-            </a:extLst>
-          </p:cNvPr>
-          <p:cNvPicPr>
-            <a:picLocks noChangeAspect="1"/>
-          </p:cNvPicPr>
-          <p:nvPr/>
-        </p:nvPicPr>
-        <p:blipFill>
-          <a:blip r:embed="rId3">
-            <a:extLst>
-              <a:ext uri="{28A0092B-C50C-407E-A947-70E740481C1C}">
-                <a14:useLocalDpi xmlns:a14="http://schemas.microsoft.com/office/drawing/2010/main" val="0"/>
-              </a:ext>
-            </a:extLst>
-          </a:blip>
-          <a:stretch>
-            <a:fillRect/>
-          </a:stretch>
-        </p:blipFill>
-        <p:spPr>
-          <a:xfrm>
-            <a:off x="62144" y="112237"/>
-            <a:ext cx="588096" cy="1228523"/>
-          </a:xfrm>
-          <a:prstGeom prst="rect">
-            <a:avLst/>
-          </a:prstGeom>
-        </p:spPr>
-      </p:pic>
     </p:spTree>
     <p:extLst>
       <p:ext uri="{BB962C8B-B14F-4D97-AF65-F5344CB8AC3E}">
@@ -7973,56 +7349,6 @@
           <a:chExt cx="0" cy="0"/>
         </a:xfrm>
       </p:grpSpPr>
-      <p:sp>
-        <p:nvSpPr>
-          <p:cNvPr id="2" name="Título 1">
-            <a:extLst>
-              <a:ext uri="{FF2B5EF4-FFF2-40B4-BE49-F238E27FC236}">
-                <a16:creationId xmlns:a16="http://schemas.microsoft.com/office/drawing/2014/main" id="{BC798918-7CB4-450A-A042-F0B538CA25DE}"/>
-              </a:ext>
-            </a:extLst>
-          </p:cNvPr>
-          <p:cNvSpPr>
-            <a:spLocks noGrp="1"/>
-          </p:cNvSpPr>
-          <p:nvPr>
-            <p:ph type="title"/>
-          </p:nvPr>
-        </p:nvSpPr>
-        <p:spPr>
-          <a:xfrm>
-            <a:off x="1032611" y="0"/>
-            <a:ext cx="10827959" cy="1574800"/>
-          </a:xfrm>
-        </p:spPr>
-        <p:txBody>
-          <a:bodyPr>
-            <a:normAutofit/>
-          </a:bodyPr>
-          <a:lstStyle/>
-          <a:p>
-            <a:pPr algn="ctr"/>
-            <a:r>
-              <a:rPr lang="pt-BR" dirty="0">
-                <a:latin typeface="AlternateGothic2 BT" panose="020B0608020202050204" pitchFamily="34" charset="0"/>
-              </a:rPr>
-              <a:t>CEA055 – Estatística e Probabilidade</a:t>
-            </a:r>
-            <a:br>
-              <a:rPr lang="pt-BR" dirty="0">
-                <a:latin typeface="AlternateGothic2 BT" panose="020B0608020202050204" pitchFamily="34" charset="0"/>
-              </a:rPr>
-            </a:br>
-            <a:r>
-              <a:rPr lang="pt-BR" sz="2200" b="1" dirty="0"/>
-              <a:t>Variáveis aleatórias continuas</a:t>
-            </a:r>
-            <a:endParaRPr lang="pt-BR" dirty="0">
-              <a:latin typeface="AlternateGothic2 BT" panose="020B0608020202050204" pitchFamily="34" charset="0"/>
-            </a:endParaRPr>
-          </a:p>
-        </p:txBody>
-      </p:sp>
       <mc:AlternateContent xmlns:mc="http://schemas.openxmlformats.org/markup-compatibility/2006" xmlns:a14="http://schemas.microsoft.com/office/drawing/2010/main">
         <mc:Choice Requires="a14">
           <p:sp>
@@ -8240,7 +7566,7 @@
         <p:spPr>
           <a:xfrm>
             <a:off x="361395" y="6488668"/>
-            <a:ext cx="2395336" cy="300210"/>
+            <a:ext cx="7620000" cy="300210"/>
           </a:xfrm>
           <a:prstGeom prst="rect">
             <a:avLst/>
@@ -8255,47 +7581,11 @@
           <a:p>
             <a:r>
               <a:rPr lang="pt-BR" sz="1351" dirty="0"/>
-              <a:t>Professor: Marcos Goulart Lima</a:t>
+              <a:t>CEA055 - Estatística e Probabilidade - Professor: Marcos Goulart Lima</a:t>
             </a:r>
           </a:p>
         </p:txBody>
       </p:sp>
-      <p:pic>
-        <p:nvPicPr>
-          <p:cNvPr id="8" name="Espaço Reservado para Conteúdo 4">
-            <a:extLst>
-              <a:ext uri="{FF2B5EF4-FFF2-40B4-BE49-F238E27FC236}">
-                <a16:creationId xmlns:a16="http://schemas.microsoft.com/office/drawing/2014/main" id="{65AB402D-D1A8-4F31-BA42-34A6F0FC69F9}"/>
-              </a:ext>
-            </a:extLst>
-          </p:cNvPr>
-          <p:cNvPicPr>
-            <a:picLocks noChangeAspect="1"/>
-          </p:cNvPicPr>
-          <p:nvPr/>
-        </p:nvPicPr>
-        <p:blipFill>
-          <a:blip r:embed="rId3">
-            <a:extLst>
-              <a:ext uri="{28A0092B-C50C-407E-A947-70E740481C1C}">
-                <a14:useLocalDpi xmlns:a14="http://schemas.microsoft.com/office/drawing/2010/main" val="0"/>
-              </a:ext>
-            </a:extLst>
-          </a:blip>
-          <a:stretch>
-            <a:fillRect/>
-          </a:stretch>
-        </p:blipFill>
-        <p:spPr>
-          <a:xfrm>
-            <a:off x="62144" y="112237"/>
-            <a:ext cx="588096" cy="1228523"/>
-          </a:xfrm>
-          <a:prstGeom prst="rect">
-            <a:avLst/>
-          </a:prstGeom>
-        </p:spPr>
-      </p:pic>
       <mc:AlternateContent xmlns:mc="http://schemas.openxmlformats.org/markup-compatibility/2006" xmlns:p14="http://schemas.microsoft.com/office/powerpoint/2010/main">
         <mc:Choice Requires="p14">
           <p:contentPart p14:bwMode="auto" r:id="rId4">
@@ -8377,56 +7667,6 @@
           <a:chExt cx="0" cy="0"/>
         </a:xfrm>
       </p:grpSpPr>
-      <p:sp>
-        <p:nvSpPr>
-          <p:cNvPr id="2" name="Título 1">
-            <a:extLst>
-              <a:ext uri="{FF2B5EF4-FFF2-40B4-BE49-F238E27FC236}">
-                <a16:creationId xmlns:a16="http://schemas.microsoft.com/office/drawing/2014/main" id="{BC798918-7CB4-450A-A042-F0B538CA25DE}"/>
-              </a:ext>
-            </a:extLst>
-          </p:cNvPr>
-          <p:cNvSpPr>
-            <a:spLocks noGrp="1"/>
-          </p:cNvSpPr>
-          <p:nvPr>
-            <p:ph type="title"/>
-          </p:nvPr>
-        </p:nvSpPr>
-        <p:spPr>
-          <a:xfrm>
-            <a:off x="1032611" y="0"/>
-            <a:ext cx="10827959" cy="1574800"/>
-          </a:xfrm>
-        </p:spPr>
-        <p:txBody>
-          <a:bodyPr>
-            <a:normAutofit/>
-          </a:bodyPr>
-          <a:lstStyle/>
-          <a:p>
-            <a:pPr algn="ctr"/>
-            <a:r>
-              <a:rPr lang="pt-BR" dirty="0">
-                <a:latin typeface="AlternateGothic2 BT" panose="020B0608020202050204" pitchFamily="34" charset="0"/>
-              </a:rPr>
-              <a:t>CEA055 – Estatística e Probabilidade</a:t>
-            </a:r>
-            <a:br>
-              <a:rPr lang="pt-BR" dirty="0">
-                <a:latin typeface="AlternateGothic2 BT" panose="020B0608020202050204" pitchFamily="34" charset="0"/>
-              </a:rPr>
-            </a:br>
-            <a:r>
-              <a:rPr lang="pt-BR" sz="2200" b="1" dirty="0"/>
-              <a:t>Variáveis aleatórias continuas</a:t>
-            </a:r>
-            <a:endParaRPr lang="pt-BR" dirty="0">
-              <a:latin typeface="AlternateGothic2 BT" panose="020B0608020202050204" pitchFamily="34" charset="0"/>
-            </a:endParaRPr>
-          </a:p>
-        </p:txBody>
-      </p:sp>
       <mc:AlternateContent xmlns:mc="http://schemas.openxmlformats.org/markup-compatibility/2006" xmlns:a14="http://schemas.microsoft.com/office/drawing/2010/main">
         <mc:Choice Requires="a14">
           <p:sp>
@@ -8963,7 +8203,7 @@
         <p:spPr>
           <a:xfrm>
             <a:off x="361395" y="6488668"/>
-            <a:ext cx="2395336" cy="300210"/>
+            <a:ext cx="7620000" cy="300210"/>
           </a:xfrm>
           <a:prstGeom prst="rect">
             <a:avLst/>
@@ -8978,47 +8218,11 @@
           <a:p>
             <a:r>
               <a:rPr lang="pt-BR" sz="1351" dirty="0"/>
-              <a:t>Professor: Marcos Goulart Lima</a:t>
+              <a:t>CEA055 - Estatística e Probabilidade - Professor: Marcos Goulart Lima</a:t>
             </a:r>
           </a:p>
         </p:txBody>
       </p:sp>
-      <p:pic>
-        <p:nvPicPr>
-          <p:cNvPr id="8" name="Espaço Reservado para Conteúdo 4">
-            <a:extLst>
-              <a:ext uri="{FF2B5EF4-FFF2-40B4-BE49-F238E27FC236}">
-                <a16:creationId xmlns:a16="http://schemas.microsoft.com/office/drawing/2014/main" id="{65AB402D-D1A8-4F31-BA42-34A6F0FC69F9}"/>
-              </a:ext>
-            </a:extLst>
-          </p:cNvPr>
-          <p:cNvPicPr>
-            <a:picLocks noChangeAspect="1"/>
-          </p:cNvPicPr>
-          <p:nvPr/>
-        </p:nvPicPr>
-        <p:blipFill>
-          <a:blip r:embed="rId3">
-            <a:extLst>
-              <a:ext uri="{28A0092B-C50C-407E-A947-70E740481C1C}">
-                <a14:useLocalDpi xmlns:a14="http://schemas.microsoft.com/office/drawing/2010/main" val="0"/>
-              </a:ext>
-            </a:extLst>
-          </a:blip>
-          <a:stretch>
-            <a:fillRect/>
-          </a:stretch>
-        </p:blipFill>
-        <p:spPr>
-          <a:xfrm>
-            <a:off x="62144" y="112237"/>
-            <a:ext cx="588096" cy="1228523"/>
-          </a:xfrm>
-          <a:prstGeom prst="rect">
-            <a:avLst/>
-          </a:prstGeom>
-        </p:spPr>
-      </p:pic>
     </p:spTree>
     <p:extLst>
       <p:ext uri="{BB962C8B-B14F-4D97-AF65-F5344CB8AC3E}">
@@ -9051,56 +8255,6 @@
       </p:grpSpPr>
       <p:sp>
         <p:nvSpPr>
-          <p:cNvPr id="2" name="Título 1">
-            <a:extLst>
-              <a:ext uri="{FF2B5EF4-FFF2-40B4-BE49-F238E27FC236}">
-                <a16:creationId xmlns:a16="http://schemas.microsoft.com/office/drawing/2014/main" id="{BC798918-7CB4-450A-A042-F0B538CA25DE}"/>
-              </a:ext>
-            </a:extLst>
-          </p:cNvPr>
-          <p:cNvSpPr>
-            <a:spLocks noGrp="1"/>
-          </p:cNvSpPr>
-          <p:nvPr>
-            <p:ph type="title"/>
-          </p:nvPr>
-        </p:nvSpPr>
-        <p:spPr>
-          <a:xfrm>
-            <a:off x="1032611" y="0"/>
-            <a:ext cx="10827959" cy="1574800"/>
-          </a:xfrm>
-        </p:spPr>
-        <p:txBody>
-          <a:bodyPr>
-            <a:normAutofit/>
-          </a:bodyPr>
-          <a:lstStyle/>
-          <a:p>
-            <a:pPr algn="ctr"/>
-            <a:r>
-              <a:rPr lang="pt-BR" dirty="0">
-                <a:latin typeface="AlternateGothic2 BT" panose="020B0608020202050204" pitchFamily="34" charset="0"/>
-              </a:rPr>
-              <a:t>CEA055 – Estatística e Probabilidade</a:t>
-            </a:r>
-            <a:br>
-              <a:rPr lang="pt-BR" dirty="0">
-                <a:latin typeface="AlternateGothic2 BT" panose="020B0608020202050204" pitchFamily="34" charset="0"/>
-              </a:rPr>
-            </a:br>
-            <a:r>
-              <a:rPr lang="pt-BR" sz="2200" b="1" dirty="0"/>
-              <a:t>Variáveis aleatórias continuas</a:t>
-            </a:r>
-            <a:endParaRPr lang="pt-BR" dirty="0">
-              <a:latin typeface="AlternateGothic2 BT" panose="020B0608020202050204" pitchFamily="34" charset="0"/>
-            </a:endParaRPr>
-          </a:p>
-        </p:txBody>
-      </p:sp>
-      <p:sp>
-        <p:nvSpPr>
           <p:cNvPr id="6" name="CaixaDeTexto 5">
             <a:extLst>
               <a:ext uri="{FF2B5EF4-FFF2-40B4-BE49-F238E27FC236}">
@@ -9153,7 +8307,7 @@
         <p:spPr>
           <a:xfrm>
             <a:off x="361395" y="6488668"/>
-            <a:ext cx="2395336" cy="300210"/>
+            <a:ext cx="7620000" cy="300210"/>
           </a:xfrm>
           <a:prstGeom prst="rect">
             <a:avLst/>
@@ -9168,47 +8322,11 @@
           <a:p>
             <a:r>
               <a:rPr lang="pt-BR" sz="1351" dirty="0"/>
-              <a:t>Professor: Marcos Goulart Lima</a:t>
+              <a:t>CEA055 - Estatística e Probabilidade - Professor: Marcos Goulart Lima</a:t>
             </a:r>
           </a:p>
         </p:txBody>
       </p:sp>
-      <p:pic>
-        <p:nvPicPr>
-          <p:cNvPr id="8" name="Espaço Reservado para Conteúdo 4">
-            <a:extLst>
-              <a:ext uri="{FF2B5EF4-FFF2-40B4-BE49-F238E27FC236}">
-                <a16:creationId xmlns:a16="http://schemas.microsoft.com/office/drawing/2014/main" id="{65AB402D-D1A8-4F31-BA42-34A6F0FC69F9}"/>
-              </a:ext>
-            </a:extLst>
-          </p:cNvPr>
-          <p:cNvPicPr>
-            <a:picLocks noChangeAspect="1"/>
-          </p:cNvPicPr>
-          <p:nvPr/>
-        </p:nvPicPr>
-        <p:blipFill>
-          <a:blip r:embed="rId2">
-            <a:extLst>
-              <a:ext uri="{28A0092B-C50C-407E-A947-70E740481C1C}">
-                <a14:useLocalDpi xmlns:a14="http://schemas.microsoft.com/office/drawing/2010/main" val="0"/>
-              </a:ext>
-            </a:extLst>
-          </a:blip>
-          <a:stretch>
-            <a:fillRect/>
-          </a:stretch>
-        </p:blipFill>
-        <p:spPr>
-          <a:xfrm>
-            <a:off x="62144" y="112237"/>
-            <a:ext cx="588096" cy="1228523"/>
-          </a:xfrm>
-          <a:prstGeom prst="rect">
-            <a:avLst/>
-          </a:prstGeom>
-        </p:spPr>
-      </p:pic>
     </p:spTree>
     <p:extLst>
       <p:ext uri="{BB962C8B-B14F-4D97-AF65-F5344CB8AC3E}">
@@ -9241,56 +8359,6 @@
       </p:grpSpPr>
       <p:sp>
         <p:nvSpPr>
-          <p:cNvPr id="2" name="Título 1">
-            <a:extLst>
-              <a:ext uri="{FF2B5EF4-FFF2-40B4-BE49-F238E27FC236}">
-                <a16:creationId xmlns:a16="http://schemas.microsoft.com/office/drawing/2014/main" id="{BC798918-7CB4-450A-A042-F0B538CA25DE}"/>
-              </a:ext>
-            </a:extLst>
-          </p:cNvPr>
-          <p:cNvSpPr>
-            <a:spLocks noGrp="1"/>
-          </p:cNvSpPr>
-          <p:nvPr>
-            <p:ph type="title"/>
-          </p:nvPr>
-        </p:nvSpPr>
-        <p:spPr>
-          <a:xfrm>
-            <a:off x="1032611" y="0"/>
-            <a:ext cx="10827959" cy="1574800"/>
-          </a:xfrm>
-        </p:spPr>
-        <p:txBody>
-          <a:bodyPr>
-            <a:normAutofit/>
-          </a:bodyPr>
-          <a:lstStyle/>
-          <a:p>
-            <a:pPr algn="ctr"/>
-            <a:r>
-              <a:rPr lang="pt-BR" dirty="0">
-                <a:latin typeface="AlternateGothic2 BT" panose="020B0608020202050204" pitchFamily="34" charset="0"/>
-              </a:rPr>
-              <a:t>CEA055 – Estatística e Probabilidade</a:t>
-            </a:r>
-            <a:br>
-              <a:rPr lang="pt-BR" dirty="0">
-                <a:latin typeface="AlternateGothic2 BT" panose="020B0608020202050204" pitchFamily="34" charset="0"/>
-              </a:rPr>
-            </a:br>
-            <a:r>
-              <a:rPr lang="pt-BR" sz="2200" b="1" dirty="0"/>
-              <a:t>Variáveis aleatórias continuas</a:t>
-            </a:r>
-            <a:endParaRPr lang="pt-BR" dirty="0">
-              <a:latin typeface="AlternateGothic2 BT" panose="020B0608020202050204" pitchFamily="34" charset="0"/>
-            </a:endParaRPr>
-          </a:p>
-        </p:txBody>
-      </p:sp>
-      <p:sp>
-        <p:nvSpPr>
           <p:cNvPr id="3" name="CaixaDeTexto 2">
             <a:extLst>
               <a:ext uri="{FF2B5EF4-FFF2-40B4-BE49-F238E27FC236}">
@@ -9304,7 +8372,7 @@
         <p:spPr>
           <a:xfrm>
             <a:off x="361395" y="6488668"/>
-            <a:ext cx="2395336" cy="300210"/>
+            <a:ext cx="7620000" cy="300210"/>
           </a:xfrm>
           <a:prstGeom prst="rect">
             <a:avLst/>
@@ -9319,47 +8387,11 @@
           <a:p>
             <a:r>
               <a:rPr lang="pt-BR" sz="1351" dirty="0"/>
-              <a:t>Professor: Marcos Goulart Lima</a:t>
+              <a:t>CEA055 - Estatística e Probabilidade - Professor: Marcos Goulart Lima</a:t>
             </a:r>
           </a:p>
         </p:txBody>
       </p:sp>
-      <p:pic>
-        <p:nvPicPr>
-          <p:cNvPr id="8" name="Espaço Reservado para Conteúdo 4">
-            <a:extLst>
-              <a:ext uri="{FF2B5EF4-FFF2-40B4-BE49-F238E27FC236}">
-                <a16:creationId xmlns:a16="http://schemas.microsoft.com/office/drawing/2014/main" id="{65AB402D-D1A8-4F31-BA42-34A6F0FC69F9}"/>
-              </a:ext>
-            </a:extLst>
-          </p:cNvPr>
-          <p:cNvPicPr>
-            <a:picLocks noChangeAspect="1"/>
-          </p:cNvPicPr>
-          <p:nvPr/>
-        </p:nvPicPr>
-        <p:blipFill>
-          <a:blip r:embed="rId2">
-            <a:extLst>
-              <a:ext uri="{28A0092B-C50C-407E-A947-70E740481C1C}">
-                <a14:useLocalDpi xmlns:a14="http://schemas.microsoft.com/office/drawing/2010/main" val="0"/>
-              </a:ext>
-            </a:extLst>
-          </a:blip>
-          <a:stretch>
-            <a:fillRect/>
-          </a:stretch>
-        </p:blipFill>
-        <p:spPr>
-          <a:xfrm>
-            <a:off x="62144" y="112237"/>
-            <a:ext cx="588096" cy="1228523"/>
-          </a:xfrm>
-          <a:prstGeom prst="rect">
-            <a:avLst/>
-          </a:prstGeom>
-        </p:spPr>
-      </p:pic>
       <mc:AlternateContent xmlns:mc="http://schemas.openxmlformats.org/markup-compatibility/2006" xmlns:p14="http://schemas.microsoft.com/office/powerpoint/2010/main">
         <mc:Choice Requires="p14">
           <p:contentPart p14:bwMode="auto" r:id="rId3">
@@ -9644,7 +8676,7 @@
         <p:spPr>
           <a:xfrm>
             <a:off x="361395" y="6488668"/>
-            <a:ext cx="2395336" cy="300210"/>
+            <a:ext cx="7620000" cy="300210"/>
           </a:xfrm>
           <a:prstGeom prst="rect">
             <a:avLst/>
@@ -9659,7 +8691,7 @@
           <a:p>
             <a:r>
               <a:rPr lang="pt-BR" sz="1351" dirty="0"/>
-              <a:t>Professor: Marcos Goulart Lima</a:t>
+              <a:t>CEA055 - Estatística e Probabilidade - Professor: Marcos Goulart Lima</a:t>
             </a:r>
           </a:p>
         </p:txBody>
@@ -9807,56 +8839,6 @@
       </p:grpSpPr>
       <p:sp>
         <p:nvSpPr>
-          <p:cNvPr id="2" name="Título 1">
-            <a:extLst>
-              <a:ext uri="{FF2B5EF4-FFF2-40B4-BE49-F238E27FC236}">
-                <a16:creationId xmlns:a16="http://schemas.microsoft.com/office/drawing/2014/main" id="{BC798918-7CB4-450A-A042-F0B538CA25DE}"/>
-              </a:ext>
-            </a:extLst>
-          </p:cNvPr>
-          <p:cNvSpPr>
-            <a:spLocks noGrp="1"/>
-          </p:cNvSpPr>
-          <p:nvPr>
-            <p:ph type="title"/>
-          </p:nvPr>
-        </p:nvSpPr>
-        <p:spPr>
-          <a:xfrm>
-            <a:off x="1032611" y="0"/>
-            <a:ext cx="10827959" cy="1574800"/>
-          </a:xfrm>
-        </p:spPr>
-        <p:txBody>
-          <a:bodyPr>
-            <a:normAutofit/>
-          </a:bodyPr>
-          <a:lstStyle/>
-          <a:p>
-            <a:pPr algn="ctr"/>
-            <a:r>
-              <a:rPr lang="pt-BR" dirty="0">
-                <a:latin typeface="AlternateGothic2 BT" panose="020B0608020202050204" pitchFamily="34" charset="0"/>
-              </a:rPr>
-              <a:t>CEA055 – Estatística e Probabilidade</a:t>
-            </a:r>
-            <a:br>
-              <a:rPr lang="pt-BR" dirty="0">
-                <a:latin typeface="AlternateGothic2 BT" panose="020B0608020202050204" pitchFamily="34" charset="0"/>
-              </a:rPr>
-            </a:br>
-            <a:r>
-              <a:rPr lang="pt-BR" sz="2200" b="1" dirty="0"/>
-              <a:t>Distribuição Normal — Atividades</a:t>
-            </a:r>
-            <a:endParaRPr lang="pt-BR" dirty="0">
-              <a:latin typeface="AlternateGothic2 BT" panose="020B0608020202050204" pitchFamily="34" charset="0"/>
-            </a:endParaRPr>
-          </a:p>
-        </p:txBody>
-      </p:sp>
-      <p:sp>
-        <p:nvSpPr>
           <p:cNvPr id="6" name="CaixaDeTexto 5">
             <a:extLst>
               <a:ext uri="{FF2B5EF4-FFF2-40B4-BE49-F238E27FC236}">
@@ -9967,7 +8949,7 @@
         <p:spPr>
           <a:xfrm>
             <a:off x="361395" y="6488668"/>
-            <a:ext cx="2395336" cy="300210"/>
+            <a:ext cx="7620000" cy="300210"/>
           </a:xfrm>
           <a:prstGeom prst="rect">
             <a:avLst/>
@@ -9982,47 +8964,11 @@
           <a:p>
             <a:r>
               <a:rPr lang="pt-BR" sz="1351" dirty="0"/>
-              <a:t>Professor: Marcos Goulart Lima</a:t>
+              <a:t>CEA055 - Estatística e Probabilidade - Professor: Marcos Goulart Lima</a:t>
             </a:r>
           </a:p>
         </p:txBody>
       </p:sp>
-      <p:pic>
-        <p:nvPicPr>
-          <p:cNvPr id="8" name="Espaço Reservado para Conteúdo 4">
-            <a:extLst>
-              <a:ext uri="{FF2B5EF4-FFF2-40B4-BE49-F238E27FC236}">
-                <a16:creationId xmlns:a16="http://schemas.microsoft.com/office/drawing/2014/main" id="{65AB402D-D1A8-4F31-BA42-34A6F0FC69F9}"/>
-              </a:ext>
-            </a:extLst>
-          </p:cNvPr>
-          <p:cNvPicPr>
-            <a:picLocks noChangeAspect="1"/>
-          </p:cNvPicPr>
-          <p:nvPr/>
-        </p:nvPicPr>
-        <p:blipFill>
-          <a:blip r:embed="rId2">
-            <a:extLst>
-              <a:ext uri="{28A0092B-C50C-407E-A947-70E740481C1C}">
-                <a14:useLocalDpi xmlns:a14="http://schemas.microsoft.com/office/drawing/2010/main" val="0"/>
-              </a:ext>
-            </a:extLst>
-          </a:blip>
-          <a:stretch>
-            <a:fillRect/>
-          </a:stretch>
-        </p:blipFill>
-        <p:spPr>
-          <a:xfrm>
-            <a:off x="62144" y="112237"/>
-            <a:ext cx="588096" cy="1228523"/>
-          </a:xfrm>
-          <a:prstGeom prst="rect">
-            <a:avLst/>
-          </a:prstGeom>
-        </p:spPr>
-      </p:pic>
     </p:spTree>
     <p:extLst>
       <p:ext uri="{BB962C8B-B14F-4D97-AF65-F5344CB8AC3E}">
@@ -10055,56 +9001,6 @@
       </p:grpSpPr>
       <p:sp>
         <p:nvSpPr>
-          <p:cNvPr id="2" name="Título 1">
-            <a:extLst>
-              <a:ext uri="{FF2B5EF4-FFF2-40B4-BE49-F238E27FC236}">
-                <a16:creationId xmlns:a16="http://schemas.microsoft.com/office/drawing/2014/main" id="{BC798918-7CB4-450A-A042-F0B538CA25DE}"/>
-              </a:ext>
-            </a:extLst>
-          </p:cNvPr>
-          <p:cNvSpPr>
-            <a:spLocks noGrp="1"/>
-          </p:cNvSpPr>
-          <p:nvPr>
-            <p:ph type="title"/>
-          </p:nvPr>
-        </p:nvSpPr>
-        <p:spPr>
-          <a:xfrm>
-            <a:off x="1032611" y="0"/>
-            <a:ext cx="10827959" cy="1574800"/>
-          </a:xfrm>
-        </p:spPr>
-        <p:txBody>
-          <a:bodyPr>
-            <a:normAutofit/>
-          </a:bodyPr>
-          <a:lstStyle/>
-          <a:p>
-            <a:pPr algn="ctr"/>
-            <a:r>
-              <a:rPr lang="pt-BR" dirty="0">
-                <a:latin typeface="AlternateGothic2 BT" panose="020B0608020202050204" pitchFamily="34" charset="0"/>
-              </a:rPr>
-              <a:t>CEA055 – Estatística e Probabilidade</a:t>
-            </a:r>
-            <a:br>
-              <a:rPr lang="pt-BR" dirty="0">
-                <a:latin typeface="AlternateGothic2 BT" panose="020B0608020202050204" pitchFamily="34" charset="0"/>
-              </a:rPr>
-            </a:br>
-            <a:r>
-              <a:rPr lang="pt-BR" sz="2200" b="1" dirty="0"/>
-              <a:t>Variáveis aleatórias continuas</a:t>
-            </a:r>
-            <a:endParaRPr lang="pt-BR" dirty="0">
-              <a:latin typeface="AlternateGothic2 BT" panose="020B0608020202050204" pitchFamily="34" charset="0"/>
-            </a:endParaRPr>
-          </a:p>
-        </p:txBody>
-      </p:sp>
-      <p:sp>
-        <p:nvSpPr>
           <p:cNvPr id="6" name="CaixaDeTexto 5">
             <a:extLst>
               <a:ext uri="{FF2B5EF4-FFF2-40B4-BE49-F238E27FC236}">
@@ -10166,7 +9062,7 @@
         <p:spPr>
           <a:xfrm>
             <a:off x="361395" y="6488668"/>
-            <a:ext cx="2395336" cy="300210"/>
+            <a:ext cx="7620000" cy="300210"/>
           </a:xfrm>
           <a:prstGeom prst="rect">
             <a:avLst/>
@@ -10181,47 +9077,11 @@
           <a:p>
             <a:r>
               <a:rPr lang="pt-BR" sz="1351" dirty="0"/>
-              <a:t>Professor: Marcos Goulart Lima</a:t>
+              <a:t>CEA055 - Estatística e Probabilidade - Professor: Marcos Goulart Lima</a:t>
             </a:r>
           </a:p>
         </p:txBody>
       </p:sp>
-      <p:pic>
-        <p:nvPicPr>
-          <p:cNvPr id="8" name="Espaço Reservado para Conteúdo 4">
-            <a:extLst>
-              <a:ext uri="{FF2B5EF4-FFF2-40B4-BE49-F238E27FC236}">
-                <a16:creationId xmlns:a16="http://schemas.microsoft.com/office/drawing/2014/main" id="{65AB402D-D1A8-4F31-BA42-34A6F0FC69F9}"/>
-              </a:ext>
-            </a:extLst>
-          </p:cNvPr>
-          <p:cNvPicPr>
-            <a:picLocks noChangeAspect="1"/>
-          </p:cNvPicPr>
-          <p:nvPr/>
-        </p:nvPicPr>
-        <p:blipFill>
-          <a:blip r:embed="rId2">
-            <a:extLst>
-              <a:ext uri="{28A0092B-C50C-407E-A947-70E740481C1C}">
-                <a14:useLocalDpi xmlns:a14="http://schemas.microsoft.com/office/drawing/2010/main" val="0"/>
-              </a:ext>
-            </a:extLst>
-          </a:blip>
-          <a:stretch>
-            <a:fillRect/>
-          </a:stretch>
-        </p:blipFill>
-        <p:spPr>
-          <a:xfrm>
-            <a:off x="62144" y="112237"/>
-            <a:ext cx="588096" cy="1228523"/>
-          </a:xfrm>
-          <a:prstGeom prst="rect">
-            <a:avLst/>
-          </a:prstGeom>
-        </p:spPr>
-      </p:pic>
       <p:pic>
         <p:nvPicPr>
           <p:cNvPr id="5" name="Imagem 4">
@@ -10282,56 +9142,6 @@
           <a:chExt cx="0" cy="0"/>
         </a:xfrm>
       </p:grpSpPr>
-      <p:sp>
-        <p:nvSpPr>
-          <p:cNvPr id="2" name="Título 1">
-            <a:extLst>
-              <a:ext uri="{FF2B5EF4-FFF2-40B4-BE49-F238E27FC236}">
-                <a16:creationId xmlns:a16="http://schemas.microsoft.com/office/drawing/2014/main" id="{BC798918-7CB4-450A-A042-F0B538CA25DE}"/>
-              </a:ext>
-            </a:extLst>
-          </p:cNvPr>
-          <p:cNvSpPr>
-            <a:spLocks noGrp="1"/>
-          </p:cNvSpPr>
-          <p:nvPr>
-            <p:ph type="title"/>
-          </p:nvPr>
-        </p:nvSpPr>
-        <p:spPr>
-          <a:xfrm>
-            <a:off x="1032611" y="0"/>
-            <a:ext cx="10827959" cy="1574800"/>
-          </a:xfrm>
-        </p:spPr>
-        <p:txBody>
-          <a:bodyPr>
-            <a:normAutofit/>
-          </a:bodyPr>
-          <a:lstStyle/>
-          <a:p>
-            <a:pPr algn="ctr"/>
-            <a:r>
-              <a:rPr lang="pt-BR" dirty="0">
-                <a:latin typeface="AlternateGothic2 BT" panose="020B0608020202050204" pitchFamily="34" charset="0"/>
-              </a:rPr>
-              <a:t>CEA055 – Estatística e Probabilidade</a:t>
-            </a:r>
-            <a:br>
-              <a:rPr lang="pt-BR" dirty="0">
-                <a:latin typeface="AlternateGothic2 BT" panose="020B0608020202050204" pitchFamily="34" charset="0"/>
-              </a:rPr>
-            </a:br>
-            <a:r>
-              <a:rPr lang="pt-BR" sz="2200" b="1" dirty="0"/>
-              <a:t>Variáveis aleatórias continuas</a:t>
-            </a:r>
-            <a:endParaRPr lang="pt-BR" dirty="0">
-              <a:latin typeface="AlternateGothic2 BT" panose="020B0608020202050204" pitchFamily="34" charset="0"/>
-            </a:endParaRPr>
-          </a:p>
-        </p:txBody>
-      </p:sp>
       <mc:AlternateContent xmlns:mc="http://schemas.openxmlformats.org/markup-compatibility/2006" xmlns:a14="http://schemas.microsoft.com/office/drawing/2010/main">
         <mc:Choice Requires="a14">
           <p:sp>
@@ -10683,7 +9493,7 @@
         <p:spPr>
           <a:xfrm>
             <a:off x="361395" y="6488668"/>
-            <a:ext cx="2395336" cy="300210"/>
+            <a:ext cx="7620000" cy="300210"/>
           </a:xfrm>
           <a:prstGeom prst="rect">
             <a:avLst/>
@@ -10698,47 +9508,11 @@
           <a:p>
             <a:r>
               <a:rPr lang="pt-BR" sz="1351" dirty="0"/>
-              <a:t>Professor: Marcos Goulart Lima</a:t>
+              <a:t>CEA055 - Estatística e Probabilidade - Professor: Marcos Goulart Lima</a:t>
             </a:r>
           </a:p>
         </p:txBody>
       </p:sp>
-      <p:pic>
-        <p:nvPicPr>
-          <p:cNvPr id="8" name="Espaço Reservado para Conteúdo 4">
-            <a:extLst>
-              <a:ext uri="{FF2B5EF4-FFF2-40B4-BE49-F238E27FC236}">
-                <a16:creationId xmlns:a16="http://schemas.microsoft.com/office/drawing/2014/main" id="{65AB402D-D1A8-4F31-BA42-34A6F0FC69F9}"/>
-              </a:ext>
-            </a:extLst>
-          </p:cNvPr>
-          <p:cNvPicPr>
-            <a:picLocks noChangeAspect="1"/>
-          </p:cNvPicPr>
-          <p:nvPr/>
-        </p:nvPicPr>
-        <p:blipFill>
-          <a:blip r:embed="rId3">
-            <a:extLst>
-              <a:ext uri="{28A0092B-C50C-407E-A947-70E740481C1C}">
-                <a14:useLocalDpi xmlns:a14="http://schemas.microsoft.com/office/drawing/2010/main" val="0"/>
-              </a:ext>
-            </a:extLst>
-          </a:blip>
-          <a:stretch>
-            <a:fillRect/>
-          </a:stretch>
-        </p:blipFill>
-        <p:spPr>
-          <a:xfrm>
-            <a:off x="62144" y="112237"/>
-            <a:ext cx="588096" cy="1228523"/>
-          </a:xfrm>
-          <a:prstGeom prst="rect">
-            <a:avLst/>
-          </a:prstGeom>
-        </p:spPr>
-      </p:pic>
     </p:spTree>
     <p:extLst>
       <p:ext uri="{BB962C8B-B14F-4D97-AF65-F5344CB8AC3E}">
@@ -10769,56 +9543,6 @@
           <a:chExt cx="0" cy="0"/>
         </a:xfrm>
       </p:grpSpPr>
-      <p:sp>
-        <p:nvSpPr>
-          <p:cNvPr id="2" name="Título 1">
-            <a:extLst>
-              <a:ext uri="{FF2B5EF4-FFF2-40B4-BE49-F238E27FC236}">
-                <a16:creationId xmlns:a16="http://schemas.microsoft.com/office/drawing/2014/main" id="{BC798918-7CB4-450A-A042-F0B538CA25DE}"/>
-              </a:ext>
-            </a:extLst>
-          </p:cNvPr>
-          <p:cNvSpPr>
-            <a:spLocks noGrp="1"/>
-          </p:cNvSpPr>
-          <p:nvPr>
-            <p:ph type="title"/>
-          </p:nvPr>
-        </p:nvSpPr>
-        <p:spPr>
-          <a:xfrm>
-            <a:off x="1032611" y="0"/>
-            <a:ext cx="10827959" cy="1574800"/>
-          </a:xfrm>
-        </p:spPr>
-        <p:txBody>
-          <a:bodyPr>
-            <a:normAutofit/>
-          </a:bodyPr>
-          <a:lstStyle/>
-          <a:p>
-            <a:pPr algn="ctr"/>
-            <a:r>
-              <a:rPr lang="pt-BR" dirty="0">
-                <a:latin typeface="AlternateGothic2 BT" panose="020B0608020202050204" pitchFamily="34" charset="0"/>
-              </a:rPr>
-              <a:t>CEA055 – Estatística e Probabilidade</a:t>
-            </a:r>
-            <a:br>
-              <a:rPr lang="pt-BR" dirty="0">
-                <a:latin typeface="AlternateGothic2 BT" panose="020B0608020202050204" pitchFamily="34" charset="0"/>
-              </a:rPr>
-            </a:br>
-            <a:r>
-              <a:rPr lang="pt-BR" sz="2200" b="1" dirty="0"/>
-              <a:t>Variáveis aleatórias continuas</a:t>
-            </a:r>
-            <a:endParaRPr lang="pt-BR" dirty="0">
-              <a:latin typeface="AlternateGothic2 BT" panose="020B0608020202050204" pitchFamily="34" charset="0"/>
-            </a:endParaRPr>
-          </a:p>
-        </p:txBody>
-      </p:sp>
       <mc:AlternateContent xmlns:mc="http://schemas.openxmlformats.org/markup-compatibility/2006" xmlns:a14="http://schemas.microsoft.com/office/drawing/2010/main">
         <mc:Choice Requires="a14">
           <p:sp>
@@ -11116,7 +9840,7 @@
         <p:spPr>
           <a:xfrm>
             <a:off x="361395" y="6488668"/>
-            <a:ext cx="2395336" cy="300210"/>
+            <a:ext cx="7620000" cy="300210"/>
           </a:xfrm>
           <a:prstGeom prst="rect">
             <a:avLst/>
@@ -11131,47 +9855,11 @@
           <a:p>
             <a:r>
               <a:rPr lang="pt-BR" sz="1351" dirty="0"/>
-              <a:t>Professor: Marcos Goulart Lima</a:t>
+              <a:t>CEA055 - Estatística e Probabilidade - Professor: Marcos Goulart Lima</a:t>
             </a:r>
           </a:p>
         </p:txBody>
       </p:sp>
-      <p:pic>
-        <p:nvPicPr>
-          <p:cNvPr id="8" name="Espaço Reservado para Conteúdo 4">
-            <a:extLst>
-              <a:ext uri="{FF2B5EF4-FFF2-40B4-BE49-F238E27FC236}">
-                <a16:creationId xmlns:a16="http://schemas.microsoft.com/office/drawing/2014/main" id="{65AB402D-D1A8-4F31-BA42-34A6F0FC69F9}"/>
-              </a:ext>
-            </a:extLst>
-          </p:cNvPr>
-          <p:cNvPicPr>
-            <a:picLocks noChangeAspect="1"/>
-          </p:cNvPicPr>
-          <p:nvPr/>
-        </p:nvPicPr>
-        <p:blipFill>
-          <a:blip r:embed="rId3">
-            <a:extLst>
-              <a:ext uri="{28A0092B-C50C-407E-A947-70E740481C1C}">
-                <a14:useLocalDpi xmlns:a14="http://schemas.microsoft.com/office/drawing/2010/main" val="0"/>
-              </a:ext>
-            </a:extLst>
-          </a:blip>
-          <a:stretch>
-            <a:fillRect/>
-          </a:stretch>
-        </p:blipFill>
-        <p:spPr>
-          <a:xfrm>
-            <a:off x="62144" y="112237"/>
-            <a:ext cx="588096" cy="1228523"/>
-          </a:xfrm>
-          <a:prstGeom prst="rect">
-            <a:avLst/>
-          </a:prstGeom>
-        </p:spPr>
-      </p:pic>
       <p:pic>
         <p:nvPicPr>
           <p:cNvPr id="7" name="Imagem 6">
@@ -11232,56 +9920,6 @@
           <a:chExt cx="0" cy="0"/>
         </a:xfrm>
       </p:grpSpPr>
-      <p:sp>
-        <p:nvSpPr>
-          <p:cNvPr id="2" name="Título 1">
-            <a:extLst>
-              <a:ext uri="{FF2B5EF4-FFF2-40B4-BE49-F238E27FC236}">
-                <a16:creationId xmlns:a16="http://schemas.microsoft.com/office/drawing/2014/main" id="{BC798918-7CB4-450A-A042-F0B538CA25DE}"/>
-              </a:ext>
-            </a:extLst>
-          </p:cNvPr>
-          <p:cNvSpPr>
-            <a:spLocks noGrp="1"/>
-          </p:cNvSpPr>
-          <p:nvPr>
-            <p:ph type="title"/>
-          </p:nvPr>
-        </p:nvSpPr>
-        <p:spPr>
-          <a:xfrm>
-            <a:off x="1032611" y="0"/>
-            <a:ext cx="10827959" cy="1574800"/>
-          </a:xfrm>
-        </p:spPr>
-        <p:txBody>
-          <a:bodyPr>
-            <a:normAutofit/>
-          </a:bodyPr>
-          <a:lstStyle/>
-          <a:p>
-            <a:pPr algn="ctr"/>
-            <a:r>
-              <a:rPr lang="pt-BR" dirty="0">
-                <a:latin typeface="AlternateGothic2 BT" panose="020B0608020202050204" pitchFamily="34" charset="0"/>
-              </a:rPr>
-              <a:t>CEA055 – Estatística e Probabilidade</a:t>
-            </a:r>
-            <a:br>
-              <a:rPr lang="pt-BR" dirty="0">
-                <a:latin typeface="AlternateGothic2 BT" panose="020B0608020202050204" pitchFamily="34" charset="0"/>
-              </a:rPr>
-            </a:br>
-            <a:r>
-              <a:rPr lang="pt-BR" sz="2200" b="1" dirty="0"/>
-              <a:t>Variáveis aleatórias continuas</a:t>
-            </a:r>
-            <a:endParaRPr lang="pt-BR" dirty="0">
-              <a:latin typeface="AlternateGothic2 BT" panose="020B0608020202050204" pitchFamily="34" charset="0"/>
-            </a:endParaRPr>
-          </a:p>
-        </p:txBody>
-      </p:sp>
       <mc:AlternateContent xmlns:mc="http://schemas.openxmlformats.org/markup-compatibility/2006" xmlns:a14="http://schemas.microsoft.com/office/drawing/2010/main">
         <mc:Choice Requires="a14">
           <p:sp>
@@ -11726,7 +10364,7 @@
         <p:spPr>
           <a:xfrm>
             <a:off x="361395" y="6488668"/>
-            <a:ext cx="2395336" cy="300210"/>
+            <a:ext cx="7620000" cy="300210"/>
           </a:xfrm>
           <a:prstGeom prst="rect">
             <a:avLst/>
@@ -11741,47 +10379,11 @@
           <a:p>
             <a:r>
               <a:rPr lang="pt-BR" sz="1351" dirty="0"/>
-              <a:t>Professor: Marcos Goulart Lima</a:t>
+              <a:t>CEA055 - Estatística e Probabilidade - Professor: Marcos Goulart Lima</a:t>
             </a:r>
           </a:p>
         </p:txBody>
       </p:sp>
-      <p:pic>
-        <p:nvPicPr>
-          <p:cNvPr id="8" name="Espaço Reservado para Conteúdo 4">
-            <a:extLst>
-              <a:ext uri="{FF2B5EF4-FFF2-40B4-BE49-F238E27FC236}">
-                <a16:creationId xmlns:a16="http://schemas.microsoft.com/office/drawing/2014/main" id="{65AB402D-D1A8-4F31-BA42-34A6F0FC69F9}"/>
-              </a:ext>
-            </a:extLst>
-          </p:cNvPr>
-          <p:cNvPicPr>
-            <a:picLocks noChangeAspect="1"/>
-          </p:cNvPicPr>
-          <p:nvPr/>
-        </p:nvPicPr>
-        <p:blipFill>
-          <a:blip r:embed="rId3">
-            <a:extLst>
-              <a:ext uri="{28A0092B-C50C-407E-A947-70E740481C1C}">
-                <a14:useLocalDpi xmlns:a14="http://schemas.microsoft.com/office/drawing/2010/main" val="0"/>
-              </a:ext>
-            </a:extLst>
-          </a:blip>
-          <a:stretch>
-            <a:fillRect/>
-          </a:stretch>
-        </p:blipFill>
-        <p:spPr>
-          <a:xfrm>
-            <a:off x="62144" y="112237"/>
-            <a:ext cx="588096" cy="1228523"/>
-          </a:xfrm>
-          <a:prstGeom prst="rect">
-            <a:avLst/>
-          </a:prstGeom>
-        </p:spPr>
-      </p:pic>
     </p:spTree>
     <p:extLst>
       <p:ext uri="{BB962C8B-B14F-4D97-AF65-F5344CB8AC3E}">
@@ -11814,56 +10416,6 @@
       </p:grpSpPr>
       <p:sp>
         <p:nvSpPr>
-          <p:cNvPr id="2" name="Título 1">
-            <a:extLst>
-              <a:ext uri="{FF2B5EF4-FFF2-40B4-BE49-F238E27FC236}">
-                <a16:creationId xmlns:a16="http://schemas.microsoft.com/office/drawing/2014/main" id="{BC798918-7CB4-450A-A042-F0B538CA25DE}"/>
-              </a:ext>
-            </a:extLst>
-          </p:cNvPr>
-          <p:cNvSpPr>
-            <a:spLocks noGrp="1"/>
-          </p:cNvSpPr>
-          <p:nvPr>
-            <p:ph type="title"/>
-          </p:nvPr>
-        </p:nvSpPr>
-        <p:spPr>
-          <a:xfrm>
-            <a:off x="1032611" y="0"/>
-            <a:ext cx="10827959" cy="1574800"/>
-          </a:xfrm>
-        </p:spPr>
-        <p:txBody>
-          <a:bodyPr>
-            <a:normAutofit/>
-          </a:bodyPr>
-          <a:lstStyle/>
-          <a:p>
-            <a:pPr algn="ctr"/>
-            <a:r>
-              <a:rPr lang="pt-BR" dirty="0">
-                <a:latin typeface="AlternateGothic2 BT" panose="020B0608020202050204" pitchFamily="34" charset="0"/>
-              </a:rPr>
-              <a:t>CEA055 – Estatística e Probabilidade</a:t>
-            </a:r>
-            <a:br>
-              <a:rPr lang="pt-BR" dirty="0">
-                <a:latin typeface="AlternateGothic2 BT" panose="020B0608020202050204" pitchFamily="34" charset="0"/>
-              </a:rPr>
-            </a:br>
-            <a:r>
-              <a:rPr lang="pt-BR" sz="2200" b="1" dirty="0"/>
-              <a:t>Variáveis aleatórias continuas</a:t>
-            </a:r>
-            <a:endParaRPr lang="pt-BR" dirty="0">
-              <a:latin typeface="AlternateGothic2 BT" panose="020B0608020202050204" pitchFamily="34" charset="0"/>
-            </a:endParaRPr>
-          </a:p>
-        </p:txBody>
-      </p:sp>
-      <p:sp>
-        <p:nvSpPr>
           <p:cNvPr id="6" name="CaixaDeTexto 5">
             <a:extLst>
               <a:ext uri="{FF2B5EF4-FFF2-40B4-BE49-F238E27FC236}">
@@ -11925,7 +10477,7 @@
         <p:spPr>
           <a:xfrm>
             <a:off x="361395" y="6488668"/>
-            <a:ext cx="2395336" cy="300210"/>
+            <a:ext cx="7620000" cy="300210"/>
           </a:xfrm>
           <a:prstGeom prst="rect">
             <a:avLst/>
@@ -11940,47 +10492,11 @@
           <a:p>
             <a:r>
               <a:rPr lang="pt-BR" sz="1351" dirty="0"/>
-              <a:t>Professor: Marcos Goulart Lima</a:t>
+              <a:t>CEA055 - Estatística e Probabilidade - Professor: Marcos Goulart Lima</a:t>
             </a:r>
           </a:p>
         </p:txBody>
       </p:sp>
-      <p:pic>
-        <p:nvPicPr>
-          <p:cNvPr id="8" name="Espaço Reservado para Conteúdo 4">
-            <a:extLst>
-              <a:ext uri="{FF2B5EF4-FFF2-40B4-BE49-F238E27FC236}">
-                <a16:creationId xmlns:a16="http://schemas.microsoft.com/office/drawing/2014/main" id="{65AB402D-D1A8-4F31-BA42-34A6F0FC69F9}"/>
-              </a:ext>
-            </a:extLst>
-          </p:cNvPr>
-          <p:cNvPicPr>
-            <a:picLocks noChangeAspect="1"/>
-          </p:cNvPicPr>
-          <p:nvPr/>
-        </p:nvPicPr>
-        <p:blipFill>
-          <a:blip r:embed="rId2">
-            <a:extLst>
-              <a:ext uri="{28A0092B-C50C-407E-A947-70E740481C1C}">
-                <a14:useLocalDpi xmlns:a14="http://schemas.microsoft.com/office/drawing/2010/main" val="0"/>
-              </a:ext>
-            </a:extLst>
-          </a:blip>
-          <a:stretch>
-            <a:fillRect/>
-          </a:stretch>
-        </p:blipFill>
-        <p:spPr>
-          <a:xfrm>
-            <a:off x="62144" y="112237"/>
-            <a:ext cx="588096" cy="1228523"/>
-          </a:xfrm>
-          <a:prstGeom prst="rect">
-            <a:avLst/>
-          </a:prstGeom>
-        </p:spPr>
-      </p:pic>
       <p:pic>
         <p:nvPicPr>
           <p:cNvPr id="7" name="Imagem 6">
@@ -12041,56 +10557,6 @@
           <a:chExt cx="0" cy="0"/>
         </a:xfrm>
       </p:grpSpPr>
-      <p:sp>
-        <p:nvSpPr>
-          <p:cNvPr id="2" name="Título 1">
-            <a:extLst>
-              <a:ext uri="{FF2B5EF4-FFF2-40B4-BE49-F238E27FC236}">
-                <a16:creationId xmlns:a16="http://schemas.microsoft.com/office/drawing/2014/main" id="{BC798918-7CB4-450A-A042-F0B538CA25DE}"/>
-              </a:ext>
-            </a:extLst>
-          </p:cNvPr>
-          <p:cNvSpPr>
-            <a:spLocks noGrp="1"/>
-          </p:cNvSpPr>
-          <p:nvPr>
-            <p:ph type="title"/>
-          </p:nvPr>
-        </p:nvSpPr>
-        <p:spPr>
-          <a:xfrm>
-            <a:off x="1032611" y="0"/>
-            <a:ext cx="10827959" cy="1574800"/>
-          </a:xfrm>
-        </p:spPr>
-        <p:txBody>
-          <a:bodyPr>
-            <a:normAutofit/>
-          </a:bodyPr>
-          <a:lstStyle/>
-          <a:p>
-            <a:pPr algn="ctr"/>
-            <a:r>
-              <a:rPr lang="pt-BR" dirty="0">
-                <a:latin typeface="AlternateGothic2 BT" panose="020B0608020202050204" pitchFamily="34" charset="0"/>
-              </a:rPr>
-              <a:t>CEA055 – Estatística e Probabilidade</a:t>
-            </a:r>
-            <a:br>
-              <a:rPr lang="pt-BR" dirty="0">
-                <a:latin typeface="AlternateGothic2 BT" panose="020B0608020202050204" pitchFamily="34" charset="0"/>
-              </a:rPr>
-            </a:br>
-            <a:r>
-              <a:rPr lang="pt-BR" sz="2200" b="1" dirty="0"/>
-              <a:t>Variáveis aleatórias continuas</a:t>
-            </a:r>
-            <a:endParaRPr lang="pt-BR" dirty="0">
-              <a:latin typeface="AlternateGothic2 BT" panose="020B0608020202050204" pitchFamily="34" charset="0"/>
-            </a:endParaRPr>
-          </a:p>
-        </p:txBody>
-      </p:sp>
       <mc:AlternateContent xmlns:mc="http://schemas.openxmlformats.org/markup-compatibility/2006" xmlns:a14="http://schemas.microsoft.com/office/drawing/2010/main">
         <mc:Choice Requires="a14">
           <p:sp>
@@ -12380,7 +10846,7 @@
         <p:spPr>
           <a:xfrm>
             <a:off x="361395" y="6488668"/>
-            <a:ext cx="2395336" cy="300210"/>
+            <a:ext cx="7620000" cy="300210"/>
           </a:xfrm>
           <a:prstGeom prst="rect">
             <a:avLst/>
@@ -12395,47 +10861,11 @@
           <a:p>
             <a:r>
               <a:rPr lang="pt-BR" sz="1351" dirty="0"/>
-              <a:t>Professor: Marcos Goulart Lima</a:t>
+              <a:t>CEA055 - Estatística e Probabilidade - Professor: Marcos Goulart Lima</a:t>
             </a:r>
           </a:p>
         </p:txBody>
       </p:sp>
-      <p:pic>
-        <p:nvPicPr>
-          <p:cNvPr id="8" name="Espaço Reservado para Conteúdo 4">
-            <a:extLst>
-              <a:ext uri="{FF2B5EF4-FFF2-40B4-BE49-F238E27FC236}">
-                <a16:creationId xmlns:a16="http://schemas.microsoft.com/office/drawing/2014/main" id="{65AB402D-D1A8-4F31-BA42-34A6F0FC69F9}"/>
-              </a:ext>
-            </a:extLst>
-          </p:cNvPr>
-          <p:cNvPicPr>
-            <a:picLocks noChangeAspect="1"/>
-          </p:cNvPicPr>
-          <p:nvPr/>
-        </p:nvPicPr>
-        <p:blipFill>
-          <a:blip r:embed="rId3">
-            <a:extLst>
-              <a:ext uri="{28A0092B-C50C-407E-A947-70E740481C1C}">
-                <a14:useLocalDpi xmlns:a14="http://schemas.microsoft.com/office/drawing/2010/main" val="0"/>
-              </a:ext>
-            </a:extLst>
-          </a:blip>
-          <a:stretch>
-            <a:fillRect/>
-          </a:stretch>
-        </p:blipFill>
-        <p:spPr>
-          <a:xfrm>
-            <a:off x="62144" y="112237"/>
-            <a:ext cx="588096" cy="1228523"/>
-          </a:xfrm>
-          <a:prstGeom prst="rect">
-            <a:avLst/>
-          </a:prstGeom>
-        </p:spPr>
-      </p:pic>
     </p:spTree>
     <p:extLst>
       <p:ext uri="{BB962C8B-B14F-4D97-AF65-F5344CB8AC3E}">
@@ -12466,56 +10896,6 @@
           <a:chExt cx="0" cy="0"/>
         </a:xfrm>
       </p:grpSpPr>
-      <p:sp>
-        <p:nvSpPr>
-          <p:cNvPr id="2" name="Título 1">
-            <a:extLst>
-              <a:ext uri="{FF2B5EF4-FFF2-40B4-BE49-F238E27FC236}">
-                <a16:creationId xmlns:a16="http://schemas.microsoft.com/office/drawing/2014/main" id="{BC798918-7CB4-450A-A042-F0B538CA25DE}"/>
-              </a:ext>
-            </a:extLst>
-          </p:cNvPr>
-          <p:cNvSpPr>
-            <a:spLocks noGrp="1"/>
-          </p:cNvSpPr>
-          <p:nvPr>
-            <p:ph type="title"/>
-          </p:nvPr>
-        </p:nvSpPr>
-        <p:spPr>
-          <a:xfrm>
-            <a:off x="1032611" y="0"/>
-            <a:ext cx="10827959" cy="1574800"/>
-          </a:xfrm>
-        </p:spPr>
-        <p:txBody>
-          <a:bodyPr>
-            <a:normAutofit/>
-          </a:bodyPr>
-          <a:lstStyle/>
-          <a:p>
-            <a:pPr algn="ctr"/>
-            <a:r>
-              <a:rPr lang="pt-BR" dirty="0">
-                <a:latin typeface="AlternateGothic2 BT" panose="020B0608020202050204" pitchFamily="34" charset="0"/>
-              </a:rPr>
-              <a:t>CEA055 – Estatística e Probabilidade</a:t>
-            </a:r>
-            <a:br>
-              <a:rPr lang="pt-BR" dirty="0">
-                <a:latin typeface="AlternateGothic2 BT" panose="020B0608020202050204" pitchFamily="34" charset="0"/>
-              </a:rPr>
-            </a:br>
-            <a:r>
-              <a:rPr lang="pt-BR" sz="2200" b="1" dirty="0"/>
-              <a:t>Variáveis aleatórias continuas</a:t>
-            </a:r>
-            <a:endParaRPr lang="pt-BR" dirty="0">
-              <a:latin typeface="AlternateGothic2 BT" panose="020B0608020202050204" pitchFamily="34" charset="0"/>
-            </a:endParaRPr>
-          </a:p>
-        </p:txBody>
-      </p:sp>
       <mc:AlternateContent xmlns:mc="http://schemas.openxmlformats.org/markup-compatibility/2006" xmlns:a14="http://schemas.microsoft.com/office/drawing/2010/main">
         <mc:Choice Requires="a14">
           <p:sp>
@@ -12922,7 +11302,7 @@
         <p:spPr>
           <a:xfrm>
             <a:off x="361395" y="6488668"/>
-            <a:ext cx="2395336" cy="300210"/>
+            <a:ext cx="7620000" cy="300210"/>
           </a:xfrm>
           <a:prstGeom prst="rect">
             <a:avLst/>
@@ -12937,47 +11317,11 @@
           <a:p>
             <a:r>
               <a:rPr lang="pt-BR" sz="1351" dirty="0"/>
-              <a:t>Professor: Marcos Goulart Lima</a:t>
+              <a:t>CEA055 - Estatística e Probabilidade - Professor: Marcos Goulart Lima</a:t>
             </a:r>
           </a:p>
         </p:txBody>
       </p:sp>
-      <p:pic>
-        <p:nvPicPr>
-          <p:cNvPr id="8" name="Espaço Reservado para Conteúdo 4">
-            <a:extLst>
-              <a:ext uri="{FF2B5EF4-FFF2-40B4-BE49-F238E27FC236}">
-                <a16:creationId xmlns:a16="http://schemas.microsoft.com/office/drawing/2014/main" id="{65AB402D-D1A8-4F31-BA42-34A6F0FC69F9}"/>
-              </a:ext>
-            </a:extLst>
-          </p:cNvPr>
-          <p:cNvPicPr>
-            <a:picLocks noChangeAspect="1"/>
-          </p:cNvPicPr>
-          <p:nvPr/>
-        </p:nvPicPr>
-        <p:blipFill>
-          <a:blip r:embed="rId3">
-            <a:extLst>
-              <a:ext uri="{28A0092B-C50C-407E-A947-70E740481C1C}">
-                <a14:useLocalDpi xmlns:a14="http://schemas.microsoft.com/office/drawing/2010/main" val="0"/>
-              </a:ext>
-            </a:extLst>
-          </a:blip>
-          <a:stretch>
-            <a:fillRect/>
-          </a:stretch>
-        </p:blipFill>
-        <p:spPr>
-          <a:xfrm>
-            <a:off x="62144" y="112237"/>
-            <a:ext cx="588096" cy="1228523"/>
-          </a:xfrm>
-          <a:prstGeom prst="rect">
-            <a:avLst/>
-          </a:prstGeom>
-        </p:spPr>
-      </p:pic>
       <p:pic>
         <p:nvPicPr>
           <p:cNvPr id="5" name="Imagem 4">

</xml_diff>